<commit_message>
Follow-up: poster visual spec scripts and regenerated diagrams
</commit_message>
<xml_diff>
--- a/DS_Capstone_Poster_FINAL.pptx
+++ b/DS_Capstone_Poster_FINAL.pptx
@@ -251,7 +251,7 @@
           <a:p>
             <a:fld id="{846CE7D5-CF57-46EF-B807-FDD0502418D4}" type="datetimeFigureOut">
               <a:rPr lang="en-US" smtClean="0"/>
-              <a:t>3/12/25</a:t>
+              <a:t>4/21/26</a:t>
             </a:fld>
             <a:endParaRPr lang="en-US"/>
           </a:p>
@@ -421,7 +421,7 @@
           <a:p>
             <a:fld id="{846CE7D5-CF57-46EF-B807-FDD0502418D4}" type="datetimeFigureOut">
               <a:rPr lang="en-US" smtClean="0"/>
-              <a:t>3/12/25</a:t>
+              <a:t>4/21/26</a:t>
             </a:fld>
             <a:endParaRPr lang="en-US"/>
           </a:p>
@@ -601,7 +601,7 @@
           <a:p>
             <a:fld id="{846CE7D5-CF57-46EF-B807-FDD0502418D4}" type="datetimeFigureOut">
               <a:rPr lang="en-US" smtClean="0"/>
-              <a:t>3/12/25</a:t>
+              <a:t>4/21/26</a:t>
             </a:fld>
             <a:endParaRPr lang="en-US"/>
           </a:p>
@@ -771,7 +771,7 @@
           <a:p>
             <a:fld id="{846CE7D5-CF57-46EF-B807-FDD0502418D4}" type="datetimeFigureOut">
               <a:rPr lang="en-US" smtClean="0"/>
-              <a:t>3/12/25</a:t>
+              <a:t>4/21/26</a:t>
             </a:fld>
             <a:endParaRPr lang="en-US"/>
           </a:p>
@@ -1017,7 +1017,7 @@
           <a:p>
             <a:fld id="{846CE7D5-CF57-46EF-B807-FDD0502418D4}" type="datetimeFigureOut">
               <a:rPr lang="en-US" smtClean="0"/>
-              <a:t>3/12/25</a:t>
+              <a:t>4/21/26</a:t>
             </a:fld>
             <a:endParaRPr lang="en-US"/>
           </a:p>
@@ -1249,7 +1249,7 @@
           <a:p>
             <a:fld id="{846CE7D5-CF57-46EF-B807-FDD0502418D4}" type="datetimeFigureOut">
               <a:rPr lang="en-US" smtClean="0"/>
-              <a:t>3/12/25</a:t>
+              <a:t>4/21/26</a:t>
             </a:fld>
             <a:endParaRPr lang="en-US"/>
           </a:p>
@@ -1616,7 +1616,7 @@
           <a:p>
             <a:fld id="{846CE7D5-CF57-46EF-B807-FDD0502418D4}" type="datetimeFigureOut">
               <a:rPr lang="en-US" smtClean="0"/>
-              <a:t>3/12/25</a:t>
+              <a:t>4/21/26</a:t>
             </a:fld>
             <a:endParaRPr lang="en-US"/>
           </a:p>
@@ -1734,7 +1734,7 @@
           <a:p>
             <a:fld id="{846CE7D5-CF57-46EF-B807-FDD0502418D4}" type="datetimeFigureOut">
               <a:rPr lang="en-US" smtClean="0"/>
-              <a:t>3/12/25</a:t>
+              <a:t>4/21/26</a:t>
             </a:fld>
             <a:endParaRPr lang="en-US"/>
           </a:p>
@@ -1829,7 +1829,7 @@
           <a:p>
             <a:fld id="{846CE7D5-CF57-46EF-B807-FDD0502418D4}" type="datetimeFigureOut">
               <a:rPr lang="en-US" smtClean="0"/>
-              <a:t>3/12/25</a:t>
+              <a:t>4/21/26</a:t>
             </a:fld>
             <a:endParaRPr lang="en-US"/>
           </a:p>
@@ -2106,7 +2106,7 @@
           <a:p>
             <a:fld id="{846CE7D5-CF57-46EF-B807-FDD0502418D4}" type="datetimeFigureOut">
               <a:rPr lang="en-US" smtClean="0"/>
-              <a:t>3/12/25</a:t>
+              <a:t>4/21/26</a:t>
             </a:fld>
             <a:endParaRPr lang="en-US"/>
           </a:p>
@@ -2363,7 +2363,7 @@
           <a:p>
             <a:fld id="{846CE7D5-CF57-46EF-B807-FDD0502418D4}" type="datetimeFigureOut">
               <a:rPr lang="en-US" smtClean="0"/>
-              <a:t>3/12/25</a:t>
+              <a:t>4/21/26</a:t>
             </a:fld>
             <a:endParaRPr lang="en-US"/>
           </a:p>
@@ -2576,7 +2576,7 @@
           <a:p>
             <a:fld id="{846CE7D5-CF57-46EF-B807-FDD0502418D4}" type="datetimeFigureOut">
               <a:rPr lang="en-US" smtClean="0"/>
-              <a:t>3/12/25</a:t>
+              <a:t>4/21/26</a:t>
             </a:fld>
             <a:endParaRPr lang="en-US"/>
           </a:p>
@@ -3109,8 +3109,8 @@
         </p:nvSpPr>
         <p:spPr>
           <a:xfrm>
-            <a:off x="12019708" y="233366"/>
-            <a:ext cx="16155090" cy="3554819"/>
+            <a:off x="8398041" y="233366"/>
+            <a:ext cx="25121937" cy="3794107"/>
           </a:xfrm>
           <a:prstGeom prst="rect">
             <a:avLst/>
@@ -3128,14 +3128,22 @@
           <a:p>
             <a:pPr algn="ctr"/>
             <a:r>
-              <a:rPr sz="5600" b="1">
-                <a:solidFill>
-                  <a:srgbClr val="FFFFFF"/>
-                </a:solidFill>
+              <a:rPr sz="6600" b="1" dirty="0">
                 <a:latin typeface="Times New Roman"/>
               </a:rPr>
-              <a:t>Predictive Supply Chain Analytics
-for Backorder Risk</a:t>
+              <a:t>Predictive Supply Chain Analytics</a:t>
+            </a:r>
+            <a:r>
+              <a:rPr lang="en-US" sz="6600" b="1" dirty="0">
+                <a:latin typeface="Times New Roman"/>
+              </a:rPr>
+              <a:t> </a:t>
+            </a:r>
+            <a:r>
+              <a:rPr sz="6600" b="1" dirty="0">
+                <a:latin typeface="Times New Roman"/>
+              </a:rPr>
+              <a:t>for Backorder Risk</a:t>
             </a:r>
           </a:p>
           <a:p>
@@ -3151,13 +3159,22 @@
               </a:spcAft>
             </a:pPr>
             <a:r>
-              <a:rPr sz="2800" b="0">
-                <a:solidFill>
-                  <a:srgbClr val="EEEEEE"/>
-                </a:solidFill>
+              <a:rPr sz="2800" b="0" dirty="0">
                 <a:latin typeface="Times New Roman"/>
               </a:rPr>
-              <a:t>When simpler models suffice — logistic baselines under temporal validation</a:t>
+              <a:t>When simpler models suffice</a:t>
+            </a:r>
+            <a:r>
+              <a:rPr lang="en-US" sz="2800" b="0" dirty="0">
+                <a:latin typeface="Times New Roman"/>
+              </a:rPr>
+              <a:t>; </a:t>
+            </a:r>
+            <a:r>
+              <a:rPr sz="2800" b="0" dirty="0">
+                <a:latin typeface="Times New Roman"/>
+              </a:rPr>
+              <a:t>logistic baselines under temporal validation</a:t>
             </a:r>
           </a:p>
           <a:p>
@@ -3170,10 +3187,7 @@
               </a:spcAft>
             </a:pPr>
             <a:r>
-              <a:rPr sz="3600" b="0">
-                <a:solidFill>
-                  <a:srgbClr val="FFFFFF"/>
-                </a:solidFill>
+              <a:rPr sz="4400" b="0" dirty="0">
                 <a:latin typeface="Times New Roman"/>
               </a:rPr>
               <a:t>Addy Cruz</a:t>
@@ -3189,10 +3203,7 @@
               </a:spcAft>
             </a:pPr>
             <a:r>
-              <a:rPr sz="3000" b="0">
-                <a:solidFill>
-                  <a:srgbClr val="EEEEEE"/>
-                </a:solidFill>
+              <a:rPr sz="4400" b="0" dirty="0">
                 <a:latin typeface="Times New Roman"/>
               </a:rPr>
               <a:t>Advisor: Dr. Liang Jingsai</a:t>
@@ -3208,10 +3219,7 @@
               </a:spcAft>
             </a:pPr>
             <a:r>
-              <a:rPr sz="3000" b="0">
-                <a:solidFill>
-                  <a:srgbClr val="EEEEEE"/>
-                </a:solidFill>
+              <a:rPr sz="2800" b="0" dirty="0">
                 <a:latin typeface="Times New Roman"/>
               </a:rPr>
               <a:t>DATA-470 Capstone  |  Data Science  |  Westminster University</a:t>
@@ -3233,8 +3241,8 @@
         </p:nvSpPr>
         <p:spPr>
           <a:xfrm>
-            <a:off x="2800882" y="4351347"/>
-            <a:ext cx="6101922" cy="923330"/>
+            <a:off x="2800881" y="4351347"/>
+            <a:ext cx="9904466" cy="923330"/>
           </a:xfrm>
           <a:prstGeom prst="rect">
             <a:avLst/>
@@ -3256,7 +3264,7 @@
               </a:spcAft>
             </a:pPr>
             <a:r>
-              <a:rPr sz="3600" b="1">
+              <a:rPr sz="4800" b="1" dirty="0">
                 <a:solidFill>
                   <a:srgbClr val="1B3A5C"/>
                 </a:solidFill>
@@ -3377,8 +3385,8 @@
         </p:nvSpPr>
         <p:spPr>
           <a:xfrm>
-            <a:off x="17078588" y="4351346"/>
-            <a:ext cx="6101922" cy="923330"/>
+            <a:off x="15549885" y="4158142"/>
+            <a:ext cx="9904465" cy="923330"/>
           </a:xfrm>
           <a:prstGeom prst="rect">
             <a:avLst/>
@@ -3400,7 +3408,7 @@
               </a:spcAft>
             </a:pPr>
             <a:r>
-              <a:rPr sz="3600" b="1">
+              <a:rPr sz="4800" b="1" dirty="0">
                 <a:solidFill>
                   <a:srgbClr val="1B3A5C"/>
                 </a:solidFill>
@@ -3426,7 +3434,7 @@
         <p:spPr>
           <a:xfrm>
             <a:off x="31857560" y="4351347"/>
-            <a:ext cx="6101922" cy="923330"/>
+            <a:ext cx="8097778" cy="923330"/>
           </a:xfrm>
           <a:prstGeom prst="rect">
             <a:avLst/>
@@ -3448,7 +3456,7 @@
               </a:spcAft>
             </a:pPr>
             <a:r>
-              <a:rPr sz="3600" b="1">
+              <a:rPr sz="3600" b="1" dirty="0">
                 <a:solidFill>
                   <a:srgbClr val="1B3A5C"/>
                 </a:solidFill>
@@ -3473,8 +3481,8 @@
         </p:nvSpPr>
         <p:spPr>
           <a:xfrm>
-            <a:off x="31857523" y="20093479"/>
-            <a:ext cx="6101922" cy="923330"/>
+            <a:off x="31857522" y="20093479"/>
+            <a:ext cx="7124793" cy="923330"/>
           </a:xfrm>
           <a:prstGeom prst="rect">
             <a:avLst/>
@@ -3496,7 +3504,7 @@
               </a:spcAft>
             </a:pPr>
             <a:r>
-              <a:rPr sz="3600" b="1">
+              <a:rPr sz="3600" b="1" dirty="0">
                 <a:solidFill>
                   <a:srgbClr val="1B3A5C"/>
                 </a:solidFill>
@@ -3877,7 +3885,7 @@
         </p:nvSpPr>
         <p:spPr>
           <a:xfrm>
-            <a:off x="12320376" y="5468382"/>
+            <a:off x="12410376" y="4963056"/>
             <a:ext cx="15888512" cy="27091877"/>
           </a:xfrm>
           <a:prstGeom prst="rect">
@@ -3900,10 +3908,10 @@
           <a:lstStyle/>
           <a:p>
             <a:pPr algn="l"/>
-            <a:endParaRPr lang="en-US"/>
-          </a:p>
-          <a:p>
-            <a:pPr algn="l">
+            <a:endParaRPr lang="en-US" dirty="0"/>
+          </a:p>
+          <a:p>
+            <a:pPr algn="ctr">
               <a:lnSpc>
                 <a:spcPct val="105000"/>
               </a:lnSpc>
@@ -3915,7 +3923,7 @@
               </a:spcAft>
             </a:pPr>
             <a:r>
-              <a:rPr sz="2600" b="1">
+              <a:rPr lang="en-US" sz="2800" b="1" u="sng" dirty="0">
                 <a:solidFill>
                   <a:srgbClr val="1B3A5C"/>
                 </a:solidFill>
@@ -3923,6 +3931,12 @@
               </a:rPr>
               <a:t>Evidence: stress splits, lineage, validation (LR vs. LGBM)</a:t>
             </a:r>
+            <a:endParaRPr sz="2800" b="1" u="sng" dirty="0">
+              <a:solidFill>
+                <a:srgbClr val="1B3A5C"/>
+              </a:solidFill>
+              <a:latin typeface="Times New Roman"/>
+            </a:endParaRPr>
           </a:p>
         </p:txBody>
       </p:sp>
@@ -4100,7 +4114,7 @@
               </a:spcAft>
             </a:pPr>
             <a:r>
-              <a:rPr sz="3200" b="1">
+              <a:rPr sz="3200" b="1" dirty="0">
                 <a:solidFill>
                   <a:srgbClr val="1B3A5C"/>
                 </a:solidFill>
@@ -4108,7 +4122,7 @@
               </a:rPr>
               <a:t>Limitations</a:t>
             </a:r>
-            <a:endParaRPr lang="en-US"/>
+            <a:endParaRPr lang="en-US" dirty="0"/>
           </a:p>
           <a:p>
             <a:pPr algn="l">
@@ -4123,7 +4137,7 @@
               </a:spcAft>
             </a:pPr>
             <a:r>
-              <a:rPr sz="2400">
+              <a:rPr sz="2400" dirty="0">
                 <a:solidFill>
                   <a:srgbClr val="333333"/>
                 </a:solidFill>
@@ -4145,7 +4159,7 @@
               </a:spcAft>
             </a:pPr>
             <a:r>
-              <a:rPr sz="3200" b="1">
+              <a:rPr sz="3200" b="1" dirty="0">
                 <a:solidFill>
                   <a:srgbClr val="1B3A5C"/>
                 </a:solidFill>
@@ -4167,7 +4181,7 @@
               </a:spcAft>
             </a:pPr>
             <a:r>
-              <a:rPr sz="2400">
+              <a:rPr sz="2400" dirty="0">
                 <a:solidFill>
                   <a:srgbClr val="333333"/>
                 </a:solidFill>
@@ -4189,7 +4203,7 @@
               </a:spcAft>
             </a:pPr>
             <a:r>
-              <a:rPr sz="3200" b="1">
+              <a:rPr sz="3200" b="1" dirty="0">
                 <a:solidFill>
                   <a:srgbClr val="1B3A5C"/>
                 </a:solidFill>
@@ -4211,7 +4225,7 @@
               </a:spcAft>
             </a:pPr>
             <a:r>
-              <a:rPr sz="2400">
+              <a:rPr sz="2400" dirty="0">
                 <a:solidFill>
                   <a:srgbClr val="333333"/>
                 </a:solidFill>
@@ -4233,7 +4247,7 @@
               </a:spcAft>
             </a:pPr>
             <a:r>
-              <a:rPr sz="2200" b="1">
+              <a:rPr sz="2200" b="1" dirty="0">
                 <a:solidFill>
                   <a:srgbClr val="666666"/>
                 </a:solidFill>
@@ -4255,13 +4269,31 @@
               </a:spcAft>
             </a:pPr>
             <a:r>
-              <a:rPr sz="2000" b="0">
+              <a:rPr sz="2000" b="0" dirty="0">
                 <a:solidFill>
                   <a:srgbClr val="888888"/>
                 </a:solidFill>
                 <a:latin typeface="Times New Roman"/>
               </a:rPr>
-              <a:t>SAP Supply Chain Dataset (BigQuery / Kaggle).</a:t>
+              <a:t>SAP Supply Chain Dataset (</a:t>
+            </a:r>
+            <a:r>
+              <a:rPr sz="2000" b="0" dirty="0" err="1">
+                <a:solidFill>
+                  <a:srgbClr val="888888"/>
+                </a:solidFill>
+                <a:latin typeface="Times New Roman"/>
+              </a:rPr>
+              <a:t>BigQuery</a:t>
+            </a:r>
+            <a:r>
+              <a:rPr sz="2000" b="0" dirty="0">
+                <a:solidFill>
+                  <a:srgbClr val="888888"/>
+                </a:solidFill>
+                <a:latin typeface="Times New Roman"/>
+              </a:rPr>
+              <a:t> / Kaggle).</a:t>
             </a:r>
           </a:p>
           <a:p>
@@ -4277,7 +4309,7 @@
               </a:spcAft>
             </a:pPr>
             <a:r>
-              <a:rPr sz="2000" b="0">
+              <a:rPr sz="2000" b="0" dirty="0">
                 <a:solidFill>
                   <a:srgbClr val="888888"/>
                 </a:solidFill>
@@ -4290,7 +4322,7 @@
       </p:sp>
       <p:pic>
         <p:nvPicPr>
-          <p:cNvPr id="30" name="Picture 29" descr="target_balance_v2_ordertime.png"/>
+          <p:cNvPr id="31" name="Picture 30" descr="showcase_model_comparison_heatmap.png"/>
           <p:cNvPicPr>
             <a:picLocks noChangeAspect="1"/>
           </p:cNvPicPr>
@@ -4304,32 +4336,8 @@
         </p:blipFill>
         <p:spPr>
           <a:xfrm>
-            <a:off x="300063" y="9839061"/>
-            <a:ext cx="11303624" cy="3395146"/>
-          </a:xfrm>
-          <a:prstGeom prst="rect">
-            <a:avLst/>
-          </a:prstGeom>
-        </p:spPr>
-      </p:pic>
-      <p:pic>
-        <p:nvPicPr>
-          <p:cNvPr id="31" name="Picture 30" descr="showcase_model_comparison_heatmap.png"/>
-          <p:cNvPicPr>
-            <a:picLocks noChangeAspect="1"/>
-          </p:cNvPicPr>
-          <p:nvPr/>
-        </p:nvPicPr>
-        <p:blipFill>
-          <a:blip r:embed="rId4"/>
-          <a:stretch>
-            <a:fillRect/>
-          </a:stretch>
-        </p:blipFill>
-        <p:spPr>
-          <a:xfrm>
-            <a:off x="12420376" y="6188382"/>
-            <a:ext cx="15688512" cy="13135938"/>
+            <a:off x="12420376" y="5693182"/>
+            <a:ext cx="15688512" cy="10284756"/>
           </a:xfrm>
           <a:prstGeom prst="rect">
             <a:avLst/>
@@ -4345,15 +4353,15 @@
           <p:nvPr/>
         </p:nvPicPr>
         <p:blipFill>
-          <a:blip r:embed="rId5"/>
+          <a:blip r:embed="rId4"/>
           <a:stretch>
             <a:fillRect/>
           </a:stretch>
         </p:blipFill>
         <p:spPr>
           <a:xfrm>
-            <a:off x="12410376" y="20112476"/>
-            <a:ext cx="7804256" cy="12347783"/>
+            <a:off x="12410376" y="15977938"/>
+            <a:ext cx="7804256" cy="16482321"/>
           </a:xfrm>
           <a:prstGeom prst="rect">
             <a:avLst/>
@@ -4369,15 +4377,15 @@
           <p:nvPr/>
         </p:nvPicPr>
         <p:blipFill>
-          <a:blip r:embed="rId6"/>
+          <a:blip r:embed="rId5"/>
           <a:stretch>
             <a:fillRect/>
           </a:stretch>
         </p:blipFill>
         <p:spPr>
           <a:xfrm>
-            <a:off x="20314632" y="20112476"/>
-            <a:ext cx="7804256" cy="12347783"/>
+            <a:off x="20259632" y="18946588"/>
+            <a:ext cx="7804256" cy="9008756"/>
           </a:xfrm>
           <a:prstGeom prst="rect">
             <a:avLst/>
@@ -4393,7 +4401,7 @@
           <p:nvPr/>
         </p:nvPicPr>
         <p:blipFill>
-          <a:blip r:embed="rId7"/>
+          <a:blip r:embed="rId6"/>
           <a:stretch>
             <a:fillRect/>
           </a:stretch>

</xml_diff>